<commit_message>
style: unify pitch deck color theme
</commit_message>
<xml_diff>
--- a/public/Trishna 3D Pitch Deck.pptx
+++ b/public/Trishna 3D Pitch Deck.pptx
@@ -2,18 +2,18 @@
 <file path=ppt/presentation.xml><?xml version="1.0" encoding="utf-8"?>
 <p:presentation xmlns:p="http://schemas.openxmlformats.org/presentationml/2006/main">
   <p:sldMasterIdLst>
-    <p:sldMasterId xmlns:r="http://schemas.openxmlformats.org/officeDocument/2006/relationships" id="2147483648" r:id="Ra3e428b645584f7f"/>
+    <p:sldMasterId xmlns:r="http://schemas.openxmlformats.org/officeDocument/2006/relationships" id="2147483648" r:id="Rb6ba70b2be8a4b21"/>
   </p:sldMasterIdLst>
   <p:notesMasterIdLst>
-    <p:notesMasterId xmlns:r="http://schemas.openxmlformats.org/officeDocument/2006/relationships" r:id="Rbbb966ede63f45b7"/>
+    <p:notesMasterId xmlns:r="http://schemas.openxmlformats.org/officeDocument/2006/relationships" r:id="R6ba75c454d1847e6"/>
   </p:notesMasterIdLst>
   <p:sldIdLst>
-    <p:sldId xmlns:r="http://schemas.openxmlformats.org/officeDocument/2006/relationships" id="256" r:id="Ra59f2ccb8ee14671"/>
-    <p:sldId xmlns:r="http://schemas.openxmlformats.org/officeDocument/2006/relationships" id="257" r:id="R2756d70bc0844661"/>
-    <p:sldId xmlns:r="http://schemas.openxmlformats.org/officeDocument/2006/relationships" id="258" r:id="R4f3e3216e19e4dd4"/>
-    <p:sldId xmlns:r="http://schemas.openxmlformats.org/officeDocument/2006/relationships" id="259" r:id="R655442cc53264ca1"/>
-    <p:sldId xmlns:r="http://schemas.openxmlformats.org/officeDocument/2006/relationships" id="260" r:id="Rdc9c89ea4c394b85"/>
-    <p:sldId xmlns:r="http://schemas.openxmlformats.org/officeDocument/2006/relationships" id="261" r:id="R1bdab1eb23484893"/>
+    <p:sldId xmlns:r="http://schemas.openxmlformats.org/officeDocument/2006/relationships" id="256" r:id="R5e4dfd7faa714420"/>
+    <p:sldId xmlns:r="http://schemas.openxmlformats.org/officeDocument/2006/relationships" id="257" r:id="Rdbd846018f814ccb"/>
+    <p:sldId xmlns:r="http://schemas.openxmlformats.org/officeDocument/2006/relationships" id="258" r:id="R65a4020ec8354c6c"/>
+    <p:sldId xmlns:r="http://schemas.openxmlformats.org/officeDocument/2006/relationships" id="259" r:id="Rbe63862c57124816"/>
+    <p:sldId xmlns:r="http://schemas.openxmlformats.org/officeDocument/2006/relationships" id="260" r:id="R84877361000f40dd"/>
+    <p:sldId xmlns:r="http://schemas.openxmlformats.org/officeDocument/2006/relationships" id="261" r:id="R0fc88edcf162467d"/>
   </p:sldIdLst>
   <p:sldSz cx="12192000" cy="6858000"/>
   <p:notesSz cx="6858000" cy="9144000"/>
@@ -955,6 +955,7 @@
                 <a:spcPts val="0"/>
               </a:spcAft>
               <a:buNone/>
+              <a:defRPr/>
             </a:lvl1pPr>
             <a:lvl2pPr marL="0" indent="0">
               <a:lnSpc>
@@ -967,6 +968,7 @@
                 <a:spcPts val="0"/>
               </a:spcAft>
               <a:buNone/>
+              <a:defRPr/>
             </a:lvl2pPr>
             <a:lvl3pPr marL="0" indent="0">
               <a:lnSpc>
@@ -979,6 +981,7 @@
                 <a:spcPts val="0"/>
               </a:spcAft>
               <a:buNone/>
+              <a:defRPr/>
             </a:lvl3pPr>
             <a:lvl4pPr marL="0" indent="0">
               <a:lnSpc>
@@ -991,6 +994,7 @@
                 <a:spcPts val="0"/>
               </a:spcAft>
               <a:buNone/>
+              <a:defRPr/>
             </a:lvl4pPr>
             <a:lvl5pPr marL="0" indent="0">
               <a:lnSpc>
@@ -1003,6 +1007,7 @@
                 <a:spcPts val="0"/>
               </a:spcAft>
               <a:buNone/>
+              <a:defRPr/>
             </a:lvl5pPr>
             <a:lvl6pPr marL="0" indent="0">
               <a:lnSpc>
@@ -1015,6 +1020,7 @@
                 <a:spcPts val="0"/>
               </a:spcAft>
               <a:buNone/>
+              <a:defRPr/>
             </a:lvl6pPr>
             <a:lvl7pPr marL="0" indent="0">
               <a:lnSpc>
@@ -1027,6 +1033,7 @@
                 <a:spcPts val="0"/>
               </a:spcAft>
               <a:buNone/>
+              <a:defRPr/>
             </a:lvl7pPr>
             <a:lvl8pPr marL="0" indent="0">
               <a:lnSpc>
@@ -1039,6 +1046,7 @@
                 <a:spcPts val="0"/>
               </a:spcAft>
               <a:buNone/>
+              <a:defRPr/>
             </a:lvl8pPr>
             <a:lvl9pPr marL="0" indent="0">
               <a:lnSpc>
@@ -1051,6 +1059,7 @@
                 <a:spcPts val="0"/>
               </a:spcAft>
               <a:buNone/>
+              <a:defRPr/>
             </a:lvl9pPr>
           </a:lstStyle>
           <a:p xmlns:a="http://schemas.openxmlformats.org/drawingml/2006/main"/>
@@ -1112,6 +1121,7 @@
                 <a:spcPts val="0"/>
               </a:spcAft>
               <a:buNone/>
+              <a:defRPr/>
             </a:lvl1pPr>
             <a:lvl2pPr marL="0" indent="0">
               <a:lnSpc>
@@ -1124,6 +1134,7 @@
                 <a:spcPts val="0"/>
               </a:spcAft>
               <a:buNone/>
+              <a:defRPr/>
             </a:lvl2pPr>
             <a:lvl3pPr marL="0" indent="0">
               <a:lnSpc>
@@ -1136,6 +1147,7 @@
                 <a:spcPts val="0"/>
               </a:spcAft>
               <a:buNone/>
+              <a:defRPr/>
             </a:lvl3pPr>
             <a:lvl4pPr marL="0" indent="0">
               <a:lnSpc>
@@ -1148,6 +1160,7 @@
                 <a:spcPts val="0"/>
               </a:spcAft>
               <a:buNone/>
+              <a:defRPr/>
             </a:lvl4pPr>
             <a:lvl5pPr marL="0" indent="0">
               <a:lnSpc>
@@ -1160,6 +1173,7 @@
                 <a:spcPts val="0"/>
               </a:spcAft>
               <a:buNone/>
+              <a:defRPr/>
             </a:lvl5pPr>
             <a:lvl6pPr marL="0" indent="0">
               <a:lnSpc>
@@ -1172,6 +1186,7 @@
                 <a:spcPts val="0"/>
               </a:spcAft>
               <a:buNone/>
+              <a:defRPr/>
             </a:lvl6pPr>
             <a:lvl7pPr marL="0" indent="0">
               <a:lnSpc>
@@ -1184,6 +1199,7 @@
                 <a:spcPts val="0"/>
               </a:spcAft>
               <a:buNone/>
+              <a:defRPr/>
             </a:lvl7pPr>
             <a:lvl8pPr marL="0" indent="0">
               <a:lnSpc>
@@ -1196,6 +1212,7 @@
                 <a:spcPts val="0"/>
               </a:spcAft>
               <a:buNone/>
+              <a:defRPr/>
             </a:lvl8pPr>
             <a:lvl9pPr marL="0" indent="0">
               <a:lnSpc>
@@ -1208,6 +1225,7 @@
                 <a:spcPts val="0"/>
               </a:spcAft>
               <a:buNone/>
+              <a:defRPr/>
             </a:lvl9pPr>
           </a:lstStyle>
           <a:p xmlns:a="http://schemas.openxmlformats.org/drawingml/2006/main"/>
@@ -1286,6 +1304,7 @@
                 <a:spcPts val="0"/>
               </a:spcAft>
               <a:buNone/>
+              <a:defRPr/>
             </a:lvl1pPr>
             <a:lvl2pPr marL="0" indent="0">
               <a:lnSpc>
@@ -1298,6 +1317,7 @@
                 <a:spcPts val="0"/>
               </a:spcAft>
               <a:buNone/>
+              <a:defRPr/>
             </a:lvl2pPr>
             <a:lvl3pPr marL="0" indent="0">
               <a:lnSpc>
@@ -1310,6 +1330,7 @@
                 <a:spcPts val="0"/>
               </a:spcAft>
               <a:buNone/>
+              <a:defRPr/>
             </a:lvl3pPr>
             <a:lvl4pPr marL="0" indent="0">
               <a:lnSpc>
@@ -1322,6 +1343,7 @@
                 <a:spcPts val="0"/>
               </a:spcAft>
               <a:buNone/>
+              <a:defRPr/>
             </a:lvl4pPr>
             <a:lvl5pPr marL="0" indent="0">
               <a:lnSpc>
@@ -1334,6 +1356,7 @@
                 <a:spcPts val="0"/>
               </a:spcAft>
               <a:buNone/>
+              <a:defRPr/>
             </a:lvl5pPr>
             <a:lvl6pPr marL="0" indent="0">
               <a:lnSpc>
@@ -1346,6 +1369,7 @@
                 <a:spcPts val="0"/>
               </a:spcAft>
               <a:buNone/>
+              <a:defRPr/>
             </a:lvl6pPr>
             <a:lvl7pPr marL="0" indent="0">
               <a:lnSpc>
@@ -1358,6 +1382,7 @@
                 <a:spcPts val="0"/>
               </a:spcAft>
               <a:buNone/>
+              <a:defRPr/>
             </a:lvl7pPr>
             <a:lvl8pPr marL="0" indent="0">
               <a:lnSpc>
@@ -1370,6 +1395,7 @@
                 <a:spcPts val="0"/>
               </a:spcAft>
               <a:buNone/>
+              <a:defRPr/>
             </a:lvl8pPr>
             <a:lvl9pPr marL="0" indent="0">
               <a:lnSpc>
@@ -1382,6 +1408,7 @@
                 <a:spcPts val="0"/>
               </a:spcAft>
               <a:buNone/>
+              <a:defRPr/>
             </a:lvl9pPr>
           </a:lstStyle>
           <a:p xmlns:a="http://schemas.openxmlformats.org/drawingml/2006/main"/>
@@ -1460,6 +1487,7 @@
                 <a:spcPts val="0"/>
               </a:spcAft>
               <a:buNone/>
+              <a:defRPr/>
             </a:lvl1pPr>
             <a:lvl2pPr marL="0" indent="0">
               <a:lnSpc>
@@ -1472,6 +1500,7 @@
                 <a:spcPts val="0"/>
               </a:spcAft>
               <a:buNone/>
+              <a:defRPr/>
             </a:lvl2pPr>
             <a:lvl3pPr marL="0" indent="0">
               <a:lnSpc>
@@ -1484,6 +1513,7 @@
                 <a:spcPts val="0"/>
               </a:spcAft>
               <a:buNone/>
+              <a:defRPr/>
             </a:lvl3pPr>
             <a:lvl4pPr marL="0" indent="0">
               <a:lnSpc>
@@ -1496,6 +1526,7 @@
                 <a:spcPts val="0"/>
               </a:spcAft>
               <a:buNone/>
+              <a:defRPr/>
             </a:lvl4pPr>
             <a:lvl5pPr marL="0" indent="0">
               <a:lnSpc>
@@ -1508,6 +1539,7 @@
                 <a:spcPts val="0"/>
               </a:spcAft>
               <a:buNone/>
+              <a:defRPr/>
             </a:lvl5pPr>
             <a:lvl6pPr marL="0" indent="0">
               <a:lnSpc>
@@ -1520,6 +1552,7 @@
                 <a:spcPts val="0"/>
               </a:spcAft>
               <a:buNone/>
+              <a:defRPr/>
             </a:lvl6pPr>
             <a:lvl7pPr marL="0" indent="0">
               <a:lnSpc>
@@ -1532,6 +1565,7 @@
                 <a:spcPts val="0"/>
               </a:spcAft>
               <a:buNone/>
+              <a:defRPr/>
             </a:lvl7pPr>
             <a:lvl8pPr marL="0" indent="0">
               <a:lnSpc>
@@ -1544,6 +1578,7 @@
                 <a:spcPts val="0"/>
               </a:spcAft>
               <a:buNone/>
+              <a:defRPr/>
             </a:lvl8pPr>
             <a:lvl9pPr marL="0" indent="0">
               <a:lnSpc>
@@ -1556,6 +1591,7 @@
                 <a:spcPts val="0"/>
               </a:spcAft>
               <a:buNone/>
+              <a:defRPr/>
             </a:lvl9pPr>
           </a:lstStyle>
           <a:p xmlns:a="http://schemas.openxmlformats.org/drawingml/2006/main"/>
@@ -1617,6 +1653,7 @@
                 <a:spcPts val="1200"/>
               </a:spcAft>
               <a:buChar char="•"/>
+              <a:defRPr/>
             </a:lvl1pPr>
             <a:lvl2pPr marL="533400" indent="-228600">
               <a:lnSpc>
@@ -1629,6 +1666,7 @@
                 <a:spcPts val="1200"/>
               </a:spcAft>
               <a:buChar char="•"/>
+              <a:defRPr/>
             </a:lvl2pPr>
             <a:lvl3pPr marL="838200" indent="-228600">
               <a:lnSpc>
@@ -1641,6 +1679,7 @@
                 <a:spcPts val="1200"/>
               </a:spcAft>
               <a:buChar char="•"/>
+              <a:defRPr/>
             </a:lvl3pPr>
             <a:lvl4pPr marL="1143000" indent="-228600">
               <a:lnSpc>
@@ -1653,6 +1692,7 @@
                 <a:spcPts val="1200"/>
               </a:spcAft>
               <a:buChar char="•"/>
+              <a:defRPr/>
             </a:lvl4pPr>
             <a:lvl5pPr marL="1447800" indent="-228600">
               <a:lnSpc>
@@ -1665,6 +1705,7 @@
                 <a:spcPts val="1200"/>
               </a:spcAft>
               <a:buChar char="•"/>
+              <a:defRPr/>
             </a:lvl5pPr>
             <a:lvl6pPr marL="1752600" indent="-228600">
               <a:lnSpc>
@@ -1677,6 +1718,7 @@
                 <a:spcPts val="1200"/>
               </a:spcAft>
               <a:buChar char="•"/>
+              <a:defRPr/>
             </a:lvl6pPr>
             <a:lvl7pPr marL="2057400" indent="-228600">
               <a:lnSpc>
@@ -1689,6 +1731,7 @@
                 <a:spcPts val="1200"/>
               </a:spcAft>
               <a:buChar char="•"/>
+              <a:defRPr/>
             </a:lvl7pPr>
             <a:lvl8pPr marL="2362200" indent="-228600">
               <a:lnSpc>
@@ -1701,6 +1744,7 @@
                 <a:spcPts val="1200"/>
               </a:spcAft>
               <a:buChar char="•"/>
+              <a:defRPr/>
             </a:lvl8pPr>
             <a:lvl9pPr marL="2667000" indent="-228600">
               <a:lnSpc>
@@ -1713,6 +1757,7 @@
                 <a:spcPts val="1200"/>
               </a:spcAft>
               <a:buChar char="•"/>
+              <a:defRPr/>
             </a:lvl9pPr>
           </a:lstStyle>
           <a:p xmlns:a="http://schemas.openxmlformats.org/drawingml/2006/main"/>
@@ -1791,6 +1836,7 @@
                 <a:spcPts val="0"/>
               </a:spcAft>
               <a:buNone/>
+              <a:defRPr/>
             </a:lvl1pPr>
             <a:lvl2pPr marL="0" indent="0">
               <a:lnSpc>
@@ -1803,6 +1849,7 @@
                 <a:spcPts val="0"/>
               </a:spcAft>
               <a:buNone/>
+              <a:defRPr/>
             </a:lvl2pPr>
             <a:lvl3pPr marL="0" indent="0">
               <a:lnSpc>
@@ -1815,6 +1862,7 @@
                 <a:spcPts val="0"/>
               </a:spcAft>
               <a:buNone/>
+              <a:defRPr/>
             </a:lvl3pPr>
             <a:lvl4pPr marL="0" indent="0">
               <a:lnSpc>
@@ -1827,6 +1875,7 @@
                 <a:spcPts val="0"/>
               </a:spcAft>
               <a:buNone/>
+              <a:defRPr/>
             </a:lvl4pPr>
             <a:lvl5pPr marL="0" indent="0">
               <a:lnSpc>
@@ -1839,6 +1888,7 @@
                 <a:spcPts val="0"/>
               </a:spcAft>
               <a:buNone/>
+              <a:defRPr/>
             </a:lvl5pPr>
             <a:lvl6pPr marL="0" indent="0">
               <a:lnSpc>
@@ -1851,6 +1901,7 @@
                 <a:spcPts val="0"/>
               </a:spcAft>
               <a:buNone/>
+              <a:defRPr/>
             </a:lvl6pPr>
             <a:lvl7pPr marL="0" indent="0">
               <a:lnSpc>
@@ -1863,6 +1914,7 @@
                 <a:spcPts val="0"/>
               </a:spcAft>
               <a:buNone/>
+              <a:defRPr/>
             </a:lvl7pPr>
             <a:lvl8pPr marL="0" indent="0">
               <a:lnSpc>
@@ -1875,6 +1927,7 @@
                 <a:spcPts val="0"/>
               </a:spcAft>
               <a:buNone/>
+              <a:defRPr/>
             </a:lvl8pPr>
             <a:lvl9pPr marL="0" indent="0">
               <a:lnSpc>
@@ -1887,6 +1940,7 @@
                 <a:spcPts val="0"/>
               </a:spcAft>
               <a:buNone/>
+              <a:defRPr/>
             </a:lvl9pPr>
           </a:lstStyle>
           <a:p xmlns:a="http://schemas.openxmlformats.org/drawingml/2006/main"/>
@@ -1948,6 +2002,7 @@
                 <a:spcPts val="1200"/>
               </a:spcAft>
               <a:buChar char="•"/>
+              <a:defRPr/>
             </a:lvl1pPr>
             <a:lvl2pPr marL="533400" indent="-228600">
               <a:lnSpc>
@@ -1960,6 +2015,7 @@
                 <a:spcPts val="1200"/>
               </a:spcAft>
               <a:buChar char="•"/>
+              <a:defRPr/>
             </a:lvl2pPr>
             <a:lvl3pPr marL="838200" indent="-228600">
               <a:lnSpc>
@@ -1972,6 +2028,7 @@
                 <a:spcPts val="1200"/>
               </a:spcAft>
               <a:buChar char="•"/>
+              <a:defRPr/>
             </a:lvl3pPr>
             <a:lvl4pPr marL="1143000" indent="-228600">
               <a:lnSpc>
@@ -1984,6 +2041,7 @@
                 <a:spcPts val="1200"/>
               </a:spcAft>
               <a:buChar char="•"/>
+              <a:defRPr/>
             </a:lvl4pPr>
             <a:lvl5pPr marL="1447800" indent="-228600">
               <a:lnSpc>
@@ -1996,6 +2054,7 @@
                 <a:spcPts val="1200"/>
               </a:spcAft>
               <a:buChar char="•"/>
+              <a:defRPr/>
             </a:lvl5pPr>
             <a:lvl6pPr marL="1752600" indent="-228600">
               <a:lnSpc>
@@ -2008,6 +2067,7 @@
                 <a:spcPts val="1200"/>
               </a:spcAft>
               <a:buChar char="•"/>
+              <a:defRPr/>
             </a:lvl6pPr>
             <a:lvl7pPr marL="2057400" indent="-228600">
               <a:lnSpc>
@@ -2020,6 +2080,7 @@
                 <a:spcPts val="1200"/>
               </a:spcAft>
               <a:buChar char="•"/>
+              <a:defRPr/>
             </a:lvl7pPr>
             <a:lvl8pPr marL="2362200" indent="-228600">
               <a:lnSpc>
@@ -2032,6 +2093,7 @@
                 <a:spcPts val="1200"/>
               </a:spcAft>
               <a:buChar char="•"/>
+              <a:defRPr/>
             </a:lvl8pPr>
             <a:lvl9pPr marL="2667000" indent="-228600">
               <a:lnSpc>
@@ -2044,6 +2106,7 @@
                 <a:spcPts val="1200"/>
               </a:spcAft>
               <a:buChar char="•"/>
+              <a:defRPr/>
             </a:lvl9pPr>
           </a:lstStyle>
           <a:p xmlns:a="http://schemas.openxmlformats.org/drawingml/2006/main"/>
@@ -2105,6 +2168,7 @@
                 <a:spcPts val="1200"/>
               </a:spcAft>
               <a:buChar char="•"/>
+              <a:defRPr/>
             </a:lvl1pPr>
             <a:lvl2pPr marL="533400" indent="-228600">
               <a:lnSpc>
@@ -2117,6 +2181,7 @@
                 <a:spcPts val="1200"/>
               </a:spcAft>
               <a:buChar char="•"/>
+              <a:defRPr/>
             </a:lvl2pPr>
             <a:lvl3pPr marL="838200" indent="-228600">
               <a:lnSpc>
@@ -2129,6 +2194,7 @@
                 <a:spcPts val="1200"/>
               </a:spcAft>
               <a:buChar char="•"/>
+              <a:defRPr/>
             </a:lvl3pPr>
             <a:lvl4pPr marL="1143000" indent="-228600">
               <a:lnSpc>
@@ -2141,6 +2207,7 @@
                 <a:spcPts val="1200"/>
               </a:spcAft>
               <a:buChar char="•"/>
+              <a:defRPr/>
             </a:lvl4pPr>
             <a:lvl5pPr marL="1447800" indent="-228600">
               <a:lnSpc>
@@ -2153,6 +2220,7 @@
                 <a:spcPts val="1200"/>
               </a:spcAft>
               <a:buChar char="•"/>
+              <a:defRPr/>
             </a:lvl5pPr>
             <a:lvl6pPr marL="1752600" indent="-228600">
               <a:lnSpc>
@@ -2165,6 +2233,7 @@
                 <a:spcPts val="1200"/>
               </a:spcAft>
               <a:buChar char="•"/>
+              <a:defRPr/>
             </a:lvl6pPr>
             <a:lvl7pPr marL="2057400" indent="-228600">
               <a:lnSpc>
@@ -2177,6 +2246,7 @@
                 <a:spcPts val="1200"/>
               </a:spcAft>
               <a:buChar char="•"/>
+              <a:defRPr/>
             </a:lvl7pPr>
             <a:lvl8pPr marL="2362200" indent="-228600">
               <a:lnSpc>
@@ -2189,6 +2259,7 @@
                 <a:spcPts val="1200"/>
               </a:spcAft>
               <a:buChar char="•"/>
+              <a:defRPr/>
             </a:lvl8pPr>
             <a:lvl9pPr marL="2667000" indent="-228600">
               <a:lnSpc>
@@ -2201,6 +2272,7 @@
                 <a:spcPts val="1200"/>
               </a:spcAft>
               <a:buChar char="•"/>
+              <a:defRPr/>
             </a:lvl9pPr>
           </a:lstStyle>
           <a:p xmlns:a="http://schemas.openxmlformats.org/drawingml/2006/main"/>
@@ -2279,6 +2351,7 @@
                 <a:spcPts val="0"/>
               </a:spcAft>
               <a:buNone/>
+              <a:defRPr/>
             </a:lvl1pPr>
             <a:lvl2pPr marL="0" indent="0">
               <a:lnSpc>
@@ -2291,6 +2364,7 @@
                 <a:spcPts val="0"/>
               </a:spcAft>
               <a:buNone/>
+              <a:defRPr/>
             </a:lvl2pPr>
             <a:lvl3pPr marL="0" indent="0">
               <a:lnSpc>
@@ -2303,6 +2377,7 @@
                 <a:spcPts val="0"/>
               </a:spcAft>
               <a:buNone/>
+              <a:defRPr/>
             </a:lvl3pPr>
             <a:lvl4pPr marL="0" indent="0">
               <a:lnSpc>
@@ -2315,6 +2390,7 @@
                 <a:spcPts val="0"/>
               </a:spcAft>
               <a:buNone/>
+              <a:defRPr/>
             </a:lvl4pPr>
             <a:lvl5pPr marL="0" indent="0">
               <a:lnSpc>
@@ -2327,6 +2403,7 @@
                 <a:spcPts val="0"/>
               </a:spcAft>
               <a:buNone/>
+              <a:defRPr/>
             </a:lvl5pPr>
             <a:lvl6pPr marL="0" indent="0">
               <a:lnSpc>
@@ -2339,6 +2416,7 @@
                 <a:spcPts val="0"/>
               </a:spcAft>
               <a:buNone/>
+              <a:defRPr/>
             </a:lvl6pPr>
             <a:lvl7pPr marL="0" indent="0">
               <a:lnSpc>
@@ -2351,6 +2429,7 @@
                 <a:spcPts val="0"/>
               </a:spcAft>
               <a:buNone/>
+              <a:defRPr/>
             </a:lvl7pPr>
             <a:lvl8pPr marL="0" indent="0">
               <a:lnSpc>
@@ -2363,6 +2442,7 @@
                 <a:spcPts val="0"/>
               </a:spcAft>
               <a:buNone/>
+              <a:defRPr/>
             </a:lvl8pPr>
             <a:lvl9pPr marL="0" indent="0">
               <a:lnSpc>
@@ -2375,6 +2455,7 @@
                 <a:spcPts val="0"/>
               </a:spcAft>
               <a:buNone/>
+              <a:defRPr/>
             </a:lvl9pPr>
           </a:lstStyle>
           <a:p xmlns:a="http://schemas.openxmlformats.org/drawingml/2006/main"/>
@@ -2436,6 +2517,7 @@
                 <a:spcPts val="1200"/>
               </a:spcAft>
               <a:buChar char="•"/>
+              <a:defRPr/>
             </a:lvl1pPr>
             <a:lvl2pPr marL="533400" indent="-228600">
               <a:lnSpc>
@@ -2448,6 +2530,7 @@
                 <a:spcPts val="1200"/>
               </a:spcAft>
               <a:buChar char="•"/>
+              <a:defRPr/>
             </a:lvl2pPr>
             <a:lvl3pPr marL="838200" indent="-228600">
               <a:lnSpc>
@@ -2460,6 +2543,7 @@
                 <a:spcPts val="1200"/>
               </a:spcAft>
               <a:buChar char="•"/>
+              <a:defRPr/>
             </a:lvl3pPr>
             <a:lvl4pPr marL="1143000" indent="-228600">
               <a:lnSpc>
@@ -2472,6 +2556,7 @@
                 <a:spcPts val="1200"/>
               </a:spcAft>
               <a:buChar char="•"/>
+              <a:defRPr/>
             </a:lvl4pPr>
             <a:lvl5pPr marL="1447800" indent="-228600">
               <a:lnSpc>
@@ -2484,6 +2569,7 @@
                 <a:spcPts val="1200"/>
               </a:spcAft>
               <a:buChar char="•"/>
+              <a:defRPr/>
             </a:lvl5pPr>
             <a:lvl6pPr marL="1752600" indent="-228600">
               <a:lnSpc>
@@ -2496,6 +2582,7 @@
                 <a:spcPts val="1200"/>
               </a:spcAft>
               <a:buChar char="•"/>
+              <a:defRPr/>
             </a:lvl6pPr>
             <a:lvl7pPr marL="2057400" indent="-228600">
               <a:lnSpc>
@@ -2508,6 +2595,7 @@
                 <a:spcPts val="1200"/>
               </a:spcAft>
               <a:buChar char="•"/>
+              <a:defRPr/>
             </a:lvl7pPr>
             <a:lvl8pPr marL="2362200" indent="-228600">
               <a:lnSpc>
@@ -2520,6 +2608,7 @@
                 <a:spcPts val="1200"/>
               </a:spcAft>
               <a:buChar char="•"/>
+              <a:defRPr/>
             </a:lvl8pPr>
             <a:lvl9pPr marL="2667000" indent="-228600">
               <a:lnSpc>
@@ -2532,6 +2621,7 @@
                 <a:spcPts val="1200"/>
               </a:spcAft>
               <a:buChar char="•"/>
+              <a:defRPr/>
             </a:lvl9pPr>
           </a:lstStyle>
           <a:p xmlns:a="http://schemas.openxmlformats.org/drawingml/2006/main"/>
@@ -2580,12 +2670,12 @@
   </p:cSld>
   <p:clrMap bg1="lt1" tx1="dk1" bg2="lt2" tx2="dk2" accent1="accent1" accent2="accent2" accent3="accent3" accent4="accent4" accent5="accent5" accent6="accent6" hlink="hlink" folHlink="folHlink"/>
   <p:sldLayoutIdLst>
-    <p:sldLayoutId xmlns:r="http://schemas.openxmlformats.org/officeDocument/2006/relationships" id="2147483649" r:id="Rab878e4fa6254787"/>
-    <p:sldLayoutId xmlns:r="http://schemas.openxmlformats.org/officeDocument/2006/relationships" id="2147483650" r:id="R481c27c1cc5641b6"/>
-    <p:sldLayoutId xmlns:r="http://schemas.openxmlformats.org/officeDocument/2006/relationships" id="2147483651" r:id="Rfcb98f69151f4a62"/>
-    <p:sldLayoutId xmlns:r="http://schemas.openxmlformats.org/officeDocument/2006/relationships" id="2147483652" r:id="R4ba8ba0037b14e77"/>
-    <p:sldLayoutId xmlns:r="http://schemas.openxmlformats.org/officeDocument/2006/relationships" id="2147483653" r:id="R76d35e8f24b34a1f"/>
-    <p:sldLayoutId xmlns:r="http://schemas.openxmlformats.org/officeDocument/2006/relationships" id="2147483654" r:id="R58b4602a07c8440e"/>
+    <p:sldLayoutId xmlns:r="http://schemas.openxmlformats.org/officeDocument/2006/relationships" id="2147483649" r:id="R329251f0abe34c9f"/>
+    <p:sldLayoutId xmlns:r="http://schemas.openxmlformats.org/officeDocument/2006/relationships" id="2147483650" r:id="Rcf45c3aece4a4403"/>
+    <p:sldLayoutId xmlns:r="http://schemas.openxmlformats.org/officeDocument/2006/relationships" id="2147483651" r:id="R6d4192bbd09e434d"/>
+    <p:sldLayoutId xmlns:r="http://schemas.openxmlformats.org/officeDocument/2006/relationships" id="2147483652" r:id="R682f4559417c486d"/>
+    <p:sldLayoutId xmlns:r="http://schemas.openxmlformats.org/officeDocument/2006/relationships" id="2147483653" r:id="R4ee4bbbb325742e0"/>
+    <p:sldLayoutId xmlns:r="http://schemas.openxmlformats.org/officeDocument/2006/relationships" id="2147483654" r:id="R645fb1fe169e4af6"/>
   </p:sldLayoutIdLst>
   <p:txStyles>
     <p:titleStyle>
@@ -3241,6 +3331,7 @@
           </a:lstStyle>
           <a:p xmlns:a="http://schemas.openxmlformats.org/drawingml/2006/main">
             <a:pPr algn="ctr">
+              <a:buNone/>
               <a:defRPr sz="1950" b="1">
                 <a:solidFill>
                   <a:srgbClr val="FFFFFF"/>
@@ -3310,6 +3401,7 @@
           </a:lstStyle>
           <a:p xmlns:a="http://schemas.openxmlformats.org/drawingml/2006/main">
             <a:pPr algn="l">
+              <a:buNone/>
               <a:defRPr sz="1200" b="1">
                 <a:solidFill>
                   <a:srgbClr val="2C6B50"/>
@@ -3379,6 +3471,7 @@
           </a:lstStyle>
           <a:p xmlns:a="http://schemas.openxmlformats.org/drawingml/2006/main">
             <a:pPr algn="l">
+              <a:buNone/>
               <a:defRPr sz="3900" b="1">
                 <a:solidFill>
                   <a:srgbClr val="153B2E"/>
@@ -3402,6 +3495,7 @@
           </a:p>
           <a:p xmlns:a="http://schemas.openxmlformats.org/drawingml/2006/main">
             <a:pPr algn="l">
+              <a:buNone/>
               <a:defRPr sz="3900" b="1">
                 <a:solidFill>
                   <a:srgbClr val="153B2E"/>
@@ -3471,6 +3565,7 @@
           </a:lstStyle>
           <a:p xmlns:a="http://schemas.openxmlformats.org/drawingml/2006/main">
             <a:pPr algn="l">
+              <a:buNone/>
               <a:defRPr sz="1650" b="0">
                 <a:solidFill>
                   <a:srgbClr val="60756A"/>
@@ -3571,6 +3666,7 @@
           </a:lstStyle>
           <a:p xmlns:a="http://schemas.openxmlformats.org/drawingml/2006/main">
             <a:pPr algn="l">
+              <a:buNone/>
               <a:defRPr sz="1500" b="1">
                 <a:solidFill>
                   <a:srgbClr val="19332A"/>
@@ -3640,6 +3736,7 @@
           </a:lstStyle>
           <a:p xmlns:a="http://schemas.openxmlformats.org/drawingml/2006/main">
             <a:pPr algn="l">
+              <a:buNone/>
               <a:defRPr sz="1275" b="0">
                 <a:solidFill>
                   <a:srgbClr val="60756A"/>
@@ -3709,6 +3806,7 @@
           </a:lstStyle>
           <a:p xmlns:a="http://schemas.openxmlformats.org/drawingml/2006/main">
             <a:pPr algn="l">
+              <a:buNone/>
               <a:defRPr sz="975" b="0">
                 <a:solidFill>
                   <a:srgbClr val="60756A"/>
@@ -3737,7 +3835,7 @@
           <p:cNvPr id="11" name="">
             <a:extLst xmlns:a="http://schemas.openxmlformats.org/drawingml/2006/main">
               <a:ext uri="{FF2B5EF4-FFF2-40B4-BE49-F238E27FC236}">
-                <a16:creationId xmlns:a16="http://schemas.microsoft.com/office/drawing/2014/main" id="{51FB2536-45C7-4CA2-A60B-CF1B1BF726DC}"/>
+                <a16:creationId xmlns:a16="http://schemas.microsoft.com/office/drawing/2014/main" id="{9A3A747B-DD0B-463E-8C9D-2D2BDA4D3461}"/>
               </a:ext>
             </a:extLst>
           </p:cNvPr>
@@ -3747,10 +3845,10 @@
           <p:nvPr/>
         </p:nvPicPr>
         <p:blipFill>
-          <a:blip xmlns:r="http://schemas.openxmlformats.org/officeDocument/2006/relationships" xmlns:a="http://schemas.openxmlformats.org/drawingml/2006/main" r:embed="Rbde97570eb4047fe">
+          <a:blip xmlns:r="http://schemas.openxmlformats.org/officeDocument/2006/relationships" xmlns:a="http://schemas.openxmlformats.org/drawingml/2006/main" r:embed="Ra2380c324aeb45cc">
             <a:extLst>
               <a:ext uri="{96DAC541-7B7A-43D3-8B79-37D633B846F1}">
-                <asvg:svgBlip xmlns:asvg="http://schemas.microsoft.com/office/drawing/2016/SVG/main" r:embed="Rbea83d3eabaf4239"/>
+                <asvg:svgBlip xmlns:asvg="http://schemas.microsoft.com/office/drawing/2016/SVG/main" r:embed="R8d68f0115a744b3e"/>
               </a:ext>
             </a:extLst>
           </a:blip>
@@ -3872,6 +3970,7 @@
           </a:lstStyle>
           <a:p xmlns:a="http://schemas.openxmlformats.org/drawingml/2006/main">
             <a:pPr algn="l">
+              <a:buNone/>
               <a:defRPr sz="975" b="1">
                 <a:solidFill>
                   <a:srgbClr val="2C6B50"/>
@@ -3941,6 +4040,7 @@
           </a:lstStyle>
           <a:p xmlns:a="http://schemas.openxmlformats.org/drawingml/2006/main">
             <a:pPr algn="r">
+              <a:buNone/>
               <a:defRPr sz="900" b="1">
                 <a:solidFill>
                   <a:srgbClr val="60756A"/>
@@ -4010,6 +4110,7 @@
           </a:lstStyle>
           <a:p xmlns:a="http://schemas.openxmlformats.org/drawingml/2006/main">
             <a:pPr algn="l">
+              <a:buNone/>
               <a:defRPr sz="3150" b="1">
                 <a:solidFill>
                   <a:srgbClr val="153B2E"/>
@@ -4033,6 +4134,7 @@
           </a:p>
           <a:p xmlns:a="http://schemas.openxmlformats.org/drawingml/2006/main">
             <a:pPr algn="l">
+              <a:buNone/>
               <a:defRPr sz="3150" b="1">
                 <a:solidFill>
                   <a:srgbClr val="153B2E"/>
@@ -4102,6 +4204,7 @@
           </a:lstStyle>
           <a:p xmlns:a="http://schemas.openxmlformats.org/drawingml/2006/main">
             <a:pPr algn="l">
+              <a:buNone/>
               <a:defRPr sz="1500" b="0">
                 <a:solidFill>
                   <a:srgbClr val="60756A"/>
@@ -4171,6 +4274,7 @@
           </a:lstStyle>
           <a:p xmlns:a="http://schemas.openxmlformats.org/drawingml/2006/main">
             <a:pPr algn="l">
+              <a:buNone/>
               <a:defRPr sz="975" b="1">
                 <a:solidFill>
                   <a:srgbClr val="E9795B"/>
@@ -4240,6 +4344,7 @@
           </a:lstStyle>
           <a:p xmlns:a="http://schemas.openxmlformats.org/drawingml/2006/main">
             <a:pPr algn="l">
+              <a:buNone/>
               <a:defRPr sz="1425" b="1">
                 <a:solidFill>
                   <a:srgbClr val="19332A"/>
@@ -4340,6 +4445,7 @@
           </a:lstStyle>
           <a:p xmlns:a="http://schemas.openxmlformats.org/drawingml/2006/main">
             <a:pPr algn="l">
+              <a:buNone/>
               <a:defRPr sz="975" b="1">
                 <a:solidFill>
                   <a:srgbClr val="E9795B"/>
@@ -4409,6 +4515,7 @@
           </a:lstStyle>
           <a:p xmlns:a="http://schemas.openxmlformats.org/drawingml/2006/main">
             <a:pPr algn="l">
+              <a:buNone/>
               <a:defRPr sz="1425" b="1">
                 <a:solidFill>
                   <a:srgbClr val="19332A"/>
@@ -4509,6 +4616,7 @@
           </a:lstStyle>
           <a:p xmlns:a="http://schemas.openxmlformats.org/drawingml/2006/main">
             <a:pPr algn="l">
+              <a:buNone/>
               <a:defRPr sz="975" b="1">
                 <a:solidFill>
                   <a:srgbClr val="E9795B"/>
@@ -4578,6 +4686,7 @@
           </a:lstStyle>
           <a:p xmlns:a="http://schemas.openxmlformats.org/drawingml/2006/main">
             <a:pPr algn="l">
+              <a:buNone/>
               <a:defRPr sz="1425" b="1">
                 <a:solidFill>
                   <a:srgbClr val="19332A"/>
@@ -4637,7 +4746,7 @@
           <p:cNvPr id="15" name="">
             <a:extLst xmlns:a="http://schemas.openxmlformats.org/drawingml/2006/main">
               <a:ext uri="{FF2B5EF4-FFF2-40B4-BE49-F238E27FC236}">
-                <a16:creationId xmlns:a16="http://schemas.microsoft.com/office/drawing/2014/main" id="{AD1C041E-E415-4924-BA67-E2CA3ED365E4}"/>
+                <a16:creationId xmlns:a16="http://schemas.microsoft.com/office/drawing/2014/main" id="{BFF99DD9-54D6-496A-9A23-291A5971B55A}"/>
               </a:ext>
             </a:extLst>
           </p:cNvPr>
@@ -4647,7 +4756,7 @@
           <p:nvPr/>
         </p:nvPicPr>
         <p:blipFill>
-          <a:blip xmlns:r="http://schemas.openxmlformats.org/officeDocument/2006/relationships" xmlns:a="http://schemas.openxmlformats.org/drawingml/2006/main" r:embed="R2e4a74cde86949e4"/>
+          <a:blip xmlns:r="http://schemas.openxmlformats.org/officeDocument/2006/relationships" xmlns:a="http://schemas.openxmlformats.org/drawingml/2006/main" r:embed="R9a787bdd5a574ed4"/>
           <a:srcRect xmlns:a="http://schemas.openxmlformats.org/drawingml/2006/main" l="6818" t="0" r="6818" b="0"/>
           <a:stretch xmlns:a="http://schemas.openxmlformats.org/drawingml/2006/main">
             <a:fillRect l="0" t="0" r="0" b="0"/>
@@ -4711,6 +4820,7 @@
           </a:lstStyle>
           <a:p xmlns:a="http://schemas.openxmlformats.org/drawingml/2006/main">
             <a:pPr algn="l">
+              <a:buNone/>
               <a:defRPr sz="1050" b="0">
                 <a:solidFill>
                   <a:srgbClr val="60756A"/>
@@ -4840,6 +4950,7 @@
           </a:lstStyle>
           <a:p xmlns:a="http://schemas.openxmlformats.org/drawingml/2006/main">
             <a:pPr algn="l">
+              <a:buNone/>
               <a:defRPr sz="975" b="1">
                 <a:solidFill>
                   <a:srgbClr val="2C6B50"/>
@@ -4909,6 +5020,7 @@
           </a:lstStyle>
           <a:p xmlns:a="http://schemas.openxmlformats.org/drawingml/2006/main">
             <a:pPr algn="r">
+              <a:buNone/>
               <a:defRPr sz="900" b="1">
                 <a:solidFill>
                   <a:srgbClr val="60756A"/>
@@ -4978,6 +5090,7 @@
           </a:lstStyle>
           <a:p xmlns:a="http://schemas.openxmlformats.org/drawingml/2006/main">
             <a:pPr algn="l">
+              <a:buNone/>
               <a:defRPr sz="3150" b="1">
                 <a:solidFill>
                   <a:srgbClr val="153B2E"/>
@@ -5047,6 +5160,7 @@
           </a:lstStyle>
           <a:p xmlns:a="http://schemas.openxmlformats.org/drawingml/2006/main">
             <a:pPr algn="l">
+              <a:buNone/>
               <a:defRPr sz="1500" b="0">
                 <a:solidFill>
                   <a:srgbClr val="60756A"/>
@@ -5075,7 +5189,7 @@
           <p:cNvPr id="6" name="">
             <a:extLst xmlns:a="http://schemas.openxmlformats.org/drawingml/2006/main">
               <a:ext uri="{FF2B5EF4-FFF2-40B4-BE49-F238E27FC236}">
-                <a16:creationId xmlns:a16="http://schemas.microsoft.com/office/drawing/2014/main" id="{D0533D6D-0A37-4203-8758-FF3830EA2A08}"/>
+                <a16:creationId xmlns:a16="http://schemas.microsoft.com/office/drawing/2014/main" id="{F5D45EA9-72BB-47C3-BB91-B2CCE36FA26A}"/>
               </a:ext>
             </a:extLst>
           </p:cNvPr>
@@ -5085,7 +5199,7 @@
           <p:nvPr/>
         </p:nvPicPr>
         <p:blipFill>
-          <a:blip xmlns:r="http://schemas.openxmlformats.org/officeDocument/2006/relationships" xmlns:a="http://schemas.openxmlformats.org/drawingml/2006/main" r:embed="Rcb6cf0eb8c6b4c31"/>
+          <a:blip xmlns:r="http://schemas.openxmlformats.org/officeDocument/2006/relationships" xmlns:a="http://schemas.openxmlformats.org/drawingml/2006/main" r:embed="R6d69afa18879473d"/>
           <a:srcRect xmlns:a="http://schemas.openxmlformats.org/drawingml/2006/main" l="0" t="20551" r="0" b="20551"/>
           <a:stretch xmlns:a="http://schemas.openxmlformats.org/drawingml/2006/main">
             <a:fillRect l="0" t="0" r="0" b="0"/>
@@ -5180,6 +5294,7 @@
           </a:lstStyle>
           <a:p xmlns:a="http://schemas.openxmlformats.org/drawingml/2006/main">
             <a:pPr algn="l">
+              <a:buNone/>
               <a:defRPr sz="2025" b="1">
                 <a:solidFill>
                   <a:srgbClr val="E9795B"/>
@@ -5249,6 +5364,7 @@
           </a:lstStyle>
           <a:p xmlns:a="http://schemas.openxmlformats.org/drawingml/2006/main">
             <a:pPr algn="l">
+              <a:buNone/>
               <a:defRPr sz="975" b="1">
                 <a:solidFill>
                   <a:srgbClr val="2C6B50"/>
@@ -5318,6 +5434,7 @@
           </a:lstStyle>
           <a:p xmlns:a="http://schemas.openxmlformats.org/drawingml/2006/main">
             <a:pPr algn="l">
+              <a:buNone/>
               <a:defRPr sz="1275" b="0">
                 <a:solidFill>
                   <a:srgbClr val="19332A"/>
@@ -5387,6 +5504,7 @@
           </a:lstStyle>
           <a:p xmlns:a="http://schemas.openxmlformats.org/drawingml/2006/main">
             <a:pPr algn="l">
+              <a:buNone/>
               <a:defRPr sz="2025" b="1">
                 <a:solidFill>
                   <a:srgbClr val="E9795B"/>
@@ -5456,6 +5574,7 @@
           </a:lstStyle>
           <a:p xmlns:a="http://schemas.openxmlformats.org/drawingml/2006/main">
             <a:pPr algn="l">
+              <a:buNone/>
               <a:defRPr sz="975" b="1">
                 <a:solidFill>
                   <a:srgbClr val="2C6B50"/>
@@ -5525,6 +5644,7 @@
           </a:lstStyle>
           <a:p xmlns:a="http://schemas.openxmlformats.org/drawingml/2006/main">
             <a:pPr algn="l">
+              <a:buNone/>
               <a:defRPr sz="1275" b="0">
                 <a:solidFill>
                   <a:srgbClr val="19332A"/>
@@ -5594,6 +5714,7 @@
           </a:lstStyle>
           <a:p xmlns:a="http://schemas.openxmlformats.org/drawingml/2006/main">
             <a:pPr algn="l">
+              <a:buNone/>
               <a:defRPr sz="2025" b="1">
                 <a:solidFill>
                   <a:srgbClr val="E9795B"/>
@@ -5663,6 +5784,7 @@
           </a:lstStyle>
           <a:p xmlns:a="http://schemas.openxmlformats.org/drawingml/2006/main">
             <a:pPr algn="l">
+              <a:buNone/>
               <a:defRPr sz="975" b="1">
                 <a:solidFill>
                   <a:srgbClr val="2C6B50"/>
@@ -5732,6 +5854,7 @@
           </a:lstStyle>
           <a:p xmlns:a="http://schemas.openxmlformats.org/drawingml/2006/main">
             <a:pPr algn="l">
+              <a:buNone/>
               <a:defRPr sz="1275" b="0">
                 <a:solidFill>
                   <a:srgbClr val="19332A"/>
@@ -5801,6 +5924,7 @@
           </a:lstStyle>
           <a:p xmlns:a="http://schemas.openxmlformats.org/drawingml/2006/main">
             <a:pPr algn="l">
+              <a:buNone/>
               <a:defRPr sz="2025" b="1">
                 <a:solidFill>
                   <a:srgbClr val="E9795B"/>
@@ -5870,6 +5994,7 @@
           </a:lstStyle>
           <a:p xmlns:a="http://schemas.openxmlformats.org/drawingml/2006/main">
             <a:pPr algn="l">
+              <a:buNone/>
               <a:defRPr sz="975" b="1">
                 <a:solidFill>
                   <a:srgbClr val="2C6B50"/>
@@ -5939,6 +6064,7 @@
           </a:lstStyle>
           <a:p xmlns:a="http://schemas.openxmlformats.org/drawingml/2006/main">
             <a:pPr algn="l">
+              <a:buNone/>
               <a:defRPr sz="1275" b="0">
                 <a:solidFill>
                   <a:srgbClr val="19332A"/>
@@ -6068,6 +6194,7 @@
           </a:lstStyle>
           <a:p xmlns:a="http://schemas.openxmlformats.org/drawingml/2006/main">
             <a:pPr algn="l">
+              <a:buNone/>
               <a:defRPr sz="975" b="1">
                 <a:solidFill>
                   <a:srgbClr val="2C6B50"/>
@@ -6137,6 +6264,7 @@
           </a:lstStyle>
           <a:p xmlns:a="http://schemas.openxmlformats.org/drawingml/2006/main">
             <a:pPr algn="r">
+              <a:buNone/>
               <a:defRPr sz="900" b="1">
                 <a:solidFill>
                   <a:srgbClr val="60756A"/>
@@ -6206,6 +6334,7 @@
           </a:lstStyle>
           <a:p xmlns:a="http://schemas.openxmlformats.org/drawingml/2006/main">
             <a:pPr algn="l">
+              <a:buNone/>
               <a:defRPr sz="3000" b="1">
                 <a:solidFill>
                   <a:srgbClr val="153B2E"/>
@@ -6275,6 +6404,7 @@
           </a:lstStyle>
           <a:p xmlns:a="http://schemas.openxmlformats.org/drawingml/2006/main">
             <a:pPr algn="l">
+              <a:buNone/>
               <a:defRPr sz="1500" b="0">
                 <a:solidFill>
                   <a:srgbClr val="60756A"/>
@@ -6344,6 +6474,7 @@
           </a:lstStyle>
           <a:p xmlns:a="http://schemas.openxmlformats.org/drawingml/2006/main">
             <a:pPr algn="l">
+              <a:buNone/>
               <a:defRPr sz="2025" b="1">
                 <a:solidFill>
                   <a:srgbClr val="E9795B"/>
@@ -6413,6 +6544,7 @@
           </a:lstStyle>
           <a:p xmlns:a="http://schemas.openxmlformats.org/drawingml/2006/main">
             <a:pPr algn="l">
+              <a:buNone/>
               <a:defRPr sz="975" b="1">
                 <a:solidFill>
                   <a:srgbClr val="2C6B50"/>
@@ -6482,6 +6614,7 @@
           </a:lstStyle>
           <a:p xmlns:a="http://schemas.openxmlformats.org/drawingml/2006/main">
             <a:pPr algn="l">
+              <a:buNone/>
               <a:defRPr sz="1875" b="1">
                 <a:solidFill>
                   <a:srgbClr val="153B2E"/>
@@ -6551,6 +6684,7 @@
           </a:lstStyle>
           <a:p xmlns:a="http://schemas.openxmlformats.org/drawingml/2006/main">
             <a:pPr algn="l">
+              <a:buNone/>
               <a:defRPr sz="1350" b="0">
                 <a:solidFill>
                   <a:srgbClr val="60756A"/>
@@ -6651,6 +6785,7 @@
           </a:lstStyle>
           <a:p xmlns:a="http://schemas.openxmlformats.org/drawingml/2006/main">
             <a:pPr algn="l">
+              <a:buNone/>
               <a:defRPr sz="2025" b="1">
                 <a:solidFill>
                   <a:srgbClr val="E9795B"/>
@@ -6720,6 +6855,7 @@
           </a:lstStyle>
           <a:p xmlns:a="http://schemas.openxmlformats.org/drawingml/2006/main">
             <a:pPr algn="l">
+              <a:buNone/>
               <a:defRPr sz="975" b="1">
                 <a:solidFill>
                   <a:srgbClr val="2C6B50"/>
@@ -6789,6 +6925,7 @@
           </a:lstStyle>
           <a:p xmlns:a="http://schemas.openxmlformats.org/drawingml/2006/main">
             <a:pPr algn="l">
+              <a:buNone/>
               <a:defRPr sz="1875" b="1">
                 <a:solidFill>
                   <a:srgbClr val="153B2E"/>
@@ -6858,6 +6995,7 @@
           </a:lstStyle>
           <a:p xmlns:a="http://schemas.openxmlformats.org/drawingml/2006/main">
             <a:pPr algn="l">
+              <a:buNone/>
               <a:defRPr sz="1350" b="0">
                 <a:solidFill>
                   <a:srgbClr val="60756A"/>
@@ -6958,6 +7096,7 @@
           </a:lstStyle>
           <a:p xmlns:a="http://schemas.openxmlformats.org/drawingml/2006/main">
             <a:pPr algn="l">
+              <a:buNone/>
               <a:defRPr sz="2025" b="1">
                 <a:solidFill>
                   <a:srgbClr val="E9795B"/>
@@ -7027,6 +7166,7 @@
           </a:lstStyle>
           <a:p xmlns:a="http://schemas.openxmlformats.org/drawingml/2006/main">
             <a:pPr algn="l">
+              <a:buNone/>
               <a:defRPr sz="975" b="1">
                 <a:solidFill>
                   <a:srgbClr val="2C6B50"/>
@@ -7096,6 +7236,7 @@
           </a:lstStyle>
           <a:p xmlns:a="http://schemas.openxmlformats.org/drawingml/2006/main">
             <a:pPr algn="l">
+              <a:buNone/>
               <a:defRPr sz="1875" b="1">
                 <a:solidFill>
                   <a:srgbClr val="153B2E"/>
@@ -7165,6 +7306,7 @@
           </a:lstStyle>
           <a:p xmlns:a="http://schemas.openxmlformats.org/drawingml/2006/main">
             <a:pPr algn="l">
+              <a:buNone/>
               <a:defRPr sz="1350" b="0">
                 <a:solidFill>
                   <a:srgbClr val="60756A"/>
@@ -7265,6 +7407,7 @@
           </a:lstStyle>
           <a:p xmlns:a="http://schemas.openxmlformats.org/drawingml/2006/main">
             <a:pPr algn="l">
+              <a:buNone/>
               <a:defRPr sz="975" b="1">
                 <a:solidFill>
                   <a:srgbClr val="E9795B"/>
@@ -7334,6 +7477,7 @@
           </a:lstStyle>
           <a:p xmlns:a="http://schemas.openxmlformats.org/drawingml/2006/main">
             <a:pPr algn="l">
+              <a:buNone/>
               <a:defRPr sz="1425" b="1">
                 <a:solidFill>
                   <a:srgbClr val="19332A"/>
@@ -7463,6 +7607,7 @@
           </a:lstStyle>
           <a:p xmlns:a="http://schemas.openxmlformats.org/drawingml/2006/main">
             <a:pPr algn="l">
+              <a:buNone/>
               <a:defRPr sz="975" b="1">
                 <a:solidFill>
                   <a:srgbClr val="2C6B50"/>
@@ -7532,6 +7677,7 @@
           </a:lstStyle>
           <a:p xmlns:a="http://schemas.openxmlformats.org/drawingml/2006/main">
             <a:pPr algn="r">
+              <a:buNone/>
               <a:defRPr sz="900" b="1">
                 <a:solidFill>
                   <a:srgbClr val="60756A"/>
@@ -7601,6 +7747,7 @@
           </a:lstStyle>
           <a:p xmlns:a="http://schemas.openxmlformats.org/drawingml/2006/main">
             <a:pPr algn="l">
+              <a:buNone/>
               <a:defRPr sz="3000" b="1">
                 <a:solidFill>
                   <a:srgbClr val="153B2E"/>
@@ -7670,6 +7817,7 @@
           </a:lstStyle>
           <a:p xmlns:a="http://schemas.openxmlformats.org/drawingml/2006/main">
             <a:pPr algn="l">
+              <a:buNone/>
               <a:defRPr sz="1500" b="0">
                 <a:solidFill>
                   <a:srgbClr val="60756A"/>
@@ -7770,6 +7918,7 @@
           </a:lstStyle>
           <a:p xmlns:a="http://schemas.openxmlformats.org/drawingml/2006/main">
             <a:pPr algn="l">
+              <a:buNone/>
               <a:defRPr sz="975" b="1">
                 <a:solidFill>
                   <a:srgbClr val="2C6B50"/>
@@ -7839,6 +7988,7 @@
           </a:lstStyle>
           <a:p xmlns:a="http://schemas.openxmlformats.org/drawingml/2006/main">
             <a:pPr algn="l">
+              <a:buNone/>
               <a:defRPr sz="1575" b="1">
                 <a:solidFill>
                   <a:srgbClr val="153B2E"/>
@@ -7908,6 +8058,7 @@
           </a:lstStyle>
           <a:p xmlns:a="http://schemas.openxmlformats.org/drawingml/2006/main">
             <a:pPr algn="l">
+              <a:buNone/>
               <a:defRPr sz="1200" b="0">
                 <a:solidFill>
                   <a:srgbClr val="60756A"/>
@@ -8008,6 +8159,7 @@
           </a:lstStyle>
           <a:p xmlns:a="http://schemas.openxmlformats.org/drawingml/2006/main">
             <a:pPr algn="l">
+              <a:buNone/>
               <a:defRPr sz="975" b="1">
                 <a:solidFill>
                   <a:srgbClr val="E9795B"/>
@@ -8077,6 +8229,7 @@
           </a:lstStyle>
           <a:p xmlns:a="http://schemas.openxmlformats.org/drawingml/2006/main">
             <a:pPr algn="l">
+              <a:buNone/>
               <a:defRPr sz="1575" b="1">
                 <a:solidFill>
                   <a:srgbClr val="153B2E"/>
@@ -8146,6 +8299,7 @@
           </a:lstStyle>
           <a:p xmlns:a="http://schemas.openxmlformats.org/drawingml/2006/main">
             <a:pPr algn="l">
+              <a:buNone/>
               <a:defRPr sz="1200" b="0">
                 <a:solidFill>
                   <a:srgbClr val="60756A"/>
@@ -8246,6 +8400,7 @@
           </a:lstStyle>
           <a:p xmlns:a="http://schemas.openxmlformats.org/drawingml/2006/main">
             <a:pPr algn="l">
+              <a:buNone/>
               <a:defRPr sz="975" b="1">
                 <a:solidFill>
                   <a:srgbClr val="2C6B50"/>
@@ -8315,6 +8470,7 @@
           </a:lstStyle>
           <a:p xmlns:a="http://schemas.openxmlformats.org/drawingml/2006/main">
             <a:pPr algn="l">
+              <a:buNone/>
               <a:defRPr sz="1575" b="1">
                 <a:solidFill>
                   <a:srgbClr val="153B2E"/>
@@ -8384,6 +8540,7 @@
           </a:lstStyle>
           <a:p xmlns:a="http://schemas.openxmlformats.org/drawingml/2006/main">
             <a:pPr algn="l">
+              <a:buNone/>
               <a:defRPr sz="1200" b="0">
                 <a:solidFill>
                   <a:srgbClr val="60756A"/>
@@ -8484,6 +8641,7 @@
           </a:lstStyle>
           <a:p xmlns:a="http://schemas.openxmlformats.org/drawingml/2006/main">
             <a:pPr algn="l">
+              <a:buNone/>
               <a:defRPr sz="975" b="1">
                 <a:solidFill>
                   <a:srgbClr val="E9795B"/>
@@ -8553,6 +8711,7 @@
           </a:lstStyle>
           <a:p xmlns:a="http://schemas.openxmlformats.org/drawingml/2006/main">
             <a:pPr algn="l">
+              <a:buNone/>
               <a:defRPr sz="1275" b="1">
                 <a:solidFill>
                   <a:srgbClr val="19332A"/>
@@ -8592,7 +8751,7 @@
     <p:bg>
       <p:bgPr>
         <a:solidFill xmlns:a="http://schemas.openxmlformats.org/drawingml/2006/main">
-          <a:srgbClr val="153B2E"/>
+          <a:srgbClr val="F5F7F2"/>
         </a:solidFill>
       </p:bgPr>
     </p:bg>
@@ -8628,7 +8787,7 @@
             <a:avLst/>
           </a:prstGeom>
           <a:solidFill xmlns:a="http://schemas.openxmlformats.org/drawingml/2006/main">
-            <a:srgbClr val="E9795B"/>
+            <a:srgbClr val="2C6B50"/>
           </a:solidFill>
           <a:ln xmlns:a="http://schemas.openxmlformats.org/drawingml/2006/main" w="0">
             <a:noFill/>
@@ -8672,7 +8831,7 @@
             <a:defPPr algn="l">
               <a:defRPr sz="975" b="1">
                 <a:solidFill>
-                  <a:srgbClr val="A8C9B0"/>
+                  <a:srgbClr val="2C6B50"/>
                 </a:solidFill>
                 <a:latin typeface="Calibri"/>
                 <a:ea typeface="Calibri"/>
@@ -8682,6 +8841,7 @@
           </a:lstStyle>
           <a:p xmlns:a="http://schemas.openxmlformats.org/drawingml/2006/main">
             <a:pPr algn="l">
+              <a:buNone/>
               <a:defRPr sz="975" b="1">
                 <a:solidFill>
                   <a:srgbClr val="A8C9B0"/>
@@ -8694,7 +8854,7 @@
             <a:r>
               <a:rPr sz="975" b="1">
                 <a:solidFill>
-                  <a:srgbClr val="A8C9B0"/>
+                  <a:srgbClr val="2C6B50"/>
                 </a:solidFill>
                 <a:latin typeface="Calibri"/>
                 <a:ea typeface="Calibri"/>
@@ -8741,7 +8901,7 @@
             <a:defPPr algn="l">
               <a:defRPr sz="3150" b="1">
                 <a:solidFill>
-                  <a:srgbClr val="FFFFFF"/>
+                  <a:srgbClr val="153B2E"/>
                 </a:solidFill>
                 <a:latin typeface="Calibri"/>
                 <a:ea typeface="Calibri"/>
@@ -8751,6 +8911,7 @@
           </a:lstStyle>
           <a:p xmlns:a="http://schemas.openxmlformats.org/drawingml/2006/main">
             <a:pPr algn="l">
+              <a:buNone/>
               <a:defRPr sz="3150" b="1">
                 <a:solidFill>
                   <a:srgbClr val="FFFFFF"/>
@@ -8763,7 +8924,7 @@
             <a:r>
               <a:rPr sz="3150" b="1">
                 <a:solidFill>
-                  <a:srgbClr val="FFFFFF"/>
+                  <a:srgbClr val="153B2E"/>
                 </a:solidFill>
                 <a:latin typeface="Calibri"/>
                 <a:ea typeface="Calibri"/>
@@ -8774,6 +8935,7 @@
           </a:p>
           <a:p xmlns:a="http://schemas.openxmlformats.org/drawingml/2006/main">
             <a:pPr algn="l">
+              <a:buNone/>
               <a:defRPr sz="3150" b="1">
                 <a:solidFill>
                   <a:srgbClr val="FFFFFF"/>
@@ -8786,7 +8948,7 @@
             <a:r>
               <a:rPr sz="3150" b="1">
                 <a:solidFill>
-                  <a:srgbClr val="FFFFFF"/>
+                  <a:srgbClr val="153B2E"/>
                 </a:solidFill>
                 <a:latin typeface="Calibri"/>
                 <a:ea typeface="Calibri"/>
@@ -8833,7 +8995,7 @@
             <a:defPPr algn="l">
               <a:defRPr sz="1500" b="0">
                 <a:solidFill>
-                  <a:srgbClr val="D5E5D8"/>
+                  <a:srgbClr val="60756A"/>
                 </a:solidFill>
                 <a:latin typeface="Calibri"/>
                 <a:ea typeface="Calibri"/>
@@ -8843,6 +9005,7 @@
           </a:lstStyle>
           <a:p xmlns:a="http://schemas.openxmlformats.org/drawingml/2006/main">
             <a:pPr algn="l">
+              <a:buNone/>
               <a:defRPr sz="1500" b="0">
                 <a:solidFill>
                   <a:srgbClr val="D5E5D8"/>
@@ -8855,7 +9018,7 @@
             <a:r>
               <a:rPr sz="1500" b="0">
                 <a:solidFill>
-                  <a:srgbClr val="D5E5D8"/>
+                  <a:srgbClr val="60756A"/>
                 </a:solidFill>
                 <a:latin typeface="Calibri"/>
                 <a:ea typeface="Calibri"/>
@@ -8912,6 +9075,7 @@
           </a:lstStyle>
           <a:p xmlns:a="http://schemas.openxmlformats.org/drawingml/2006/main">
             <a:pPr algn="l">
+              <a:buNone/>
               <a:defRPr sz="1350" b="1">
                 <a:solidFill>
                   <a:srgbClr val="E9795B"/>
@@ -8971,7 +9135,7 @@
             <a:defPPr algn="l">
               <a:defRPr sz="975" b="1">
                 <a:solidFill>
-                  <a:srgbClr val="A8C9B0"/>
+                  <a:srgbClr val="2C6B50"/>
                 </a:solidFill>
                 <a:latin typeface="Calibri"/>
                 <a:ea typeface="Calibri"/>
@@ -8981,6 +9145,7 @@
           </a:lstStyle>
           <a:p xmlns:a="http://schemas.openxmlformats.org/drawingml/2006/main">
             <a:pPr algn="l">
+              <a:buNone/>
               <a:defRPr sz="975" b="1">
                 <a:solidFill>
                   <a:srgbClr val="A8C9B0"/>
@@ -8993,7 +9158,7 @@
             <a:r>
               <a:rPr sz="975" b="1">
                 <a:solidFill>
-                  <a:srgbClr val="A8C9B0"/>
+                  <a:srgbClr val="2C6B50"/>
                 </a:solidFill>
                 <a:latin typeface="Calibri"/>
                 <a:ea typeface="Calibri"/>
@@ -9040,7 +9205,7 @@
             <a:defPPr algn="l">
               <a:defRPr sz="1350" b="0">
                 <a:solidFill>
-                  <a:srgbClr val="FFFFFF"/>
+                  <a:srgbClr val="19332A"/>
                 </a:solidFill>
                 <a:latin typeface="Calibri"/>
                 <a:ea typeface="Calibri"/>
@@ -9050,6 +9215,7 @@
           </a:lstStyle>
           <a:p xmlns:a="http://schemas.openxmlformats.org/drawingml/2006/main">
             <a:pPr algn="l">
+              <a:buNone/>
               <a:defRPr sz="1350" b="0">
                 <a:solidFill>
                   <a:srgbClr val="FFFFFF"/>
@@ -9062,7 +9228,7 @@
             <a:r>
               <a:rPr sz="1350" b="0">
                 <a:solidFill>
-                  <a:srgbClr val="FFFFFF"/>
+                  <a:srgbClr val="19332A"/>
                 </a:solidFill>
                 <a:latin typeface="Calibri"/>
                 <a:ea typeface="Calibri"/>
@@ -9119,6 +9285,7 @@
           </a:lstStyle>
           <a:p xmlns:a="http://schemas.openxmlformats.org/drawingml/2006/main">
             <a:pPr algn="l">
+              <a:buNone/>
               <a:defRPr sz="1350" b="1">
                 <a:solidFill>
                   <a:srgbClr val="E9795B"/>
@@ -9178,7 +9345,7 @@
             <a:defPPr algn="l">
               <a:defRPr sz="975" b="1">
                 <a:solidFill>
-                  <a:srgbClr val="A8C9B0"/>
+                  <a:srgbClr val="2C6B50"/>
                 </a:solidFill>
                 <a:latin typeface="Calibri"/>
                 <a:ea typeface="Calibri"/>
@@ -9188,6 +9355,7 @@
           </a:lstStyle>
           <a:p xmlns:a="http://schemas.openxmlformats.org/drawingml/2006/main">
             <a:pPr algn="l">
+              <a:buNone/>
               <a:defRPr sz="975" b="1">
                 <a:solidFill>
                   <a:srgbClr val="A8C9B0"/>
@@ -9200,7 +9368,7 @@
             <a:r>
               <a:rPr sz="975" b="1">
                 <a:solidFill>
-                  <a:srgbClr val="A8C9B0"/>
+                  <a:srgbClr val="2C6B50"/>
                 </a:solidFill>
                 <a:latin typeface="Calibri"/>
                 <a:ea typeface="Calibri"/>
@@ -9247,7 +9415,7 @@
             <a:defPPr algn="l">
               <a:defRPr sz="1350" b="0">
                 <a:solidFill>
-                  <a:srgbClr val="FFFFFF"/>
+                  <a:srgbClr val="19332A"/>
                 </a:solidFill>
                 <a:latin typeface="Calibri"/>
                 <a:ea typeface="Calibri"/>
@@ -9257,6 +9425,7 @@
           </a:lstStyle>
           <a:p xmlns:a="http://schemas.openxmlformats.org/drawingml/2006/main">
             <a:pPr algn="l">
+              <a:buNone/>
               <a:defRPr sz="1350" b="0">
                 <a:solidFill>
                   <a:srgbClr val="FFFFFF"/>
@@ -9269,7 +9438,7 @@
             <a:r>
               <a:rPr sz="1350" b="0">
                 <a:solidFill>
-                  <a:srgbClr val="FFFFFF"/>
+                  <a:srgbClr val="19332A"/>
                 </a:solidFill>
                 <a:latin typeface="Calibri"/>
                 <a:ea typeface="Calibri"/>
@@ -9326,6 +9495,7 @@
           </a:lstStyle>
           <a:p xmlns:a="http://schemas.openxmlformats.org/drawingml/2006/main">
             <a:pPr algn="l">
+              <a:buNone/>
               <a:defRPr sz="1350" b="1">
                 <a:solidFill>
                   <a:srgbClr val="E9795B"/>
@@ -9385,7 +9555,7 @@
             <a:defPPr algn="l">
               <a:defRPr sz="975" b="1">
                 <a:solidFill>
-                  <a:srgbClr val="A8C9B0"/>
+                  <a:srgbClr val="2C6B50"/>
                 </a:solidFill>
                 <a:latin typeface="Calibri"/>
                 <a:ea typeface="Calibri"/>
@@ -9395,6 +9565,7 @@
           </a:lstStyle>
           <a:p xmlns:a="http://schemas.openxmlformats.org/drawingml/2006/main">
             <a:pPr algn="l">
+              <a:buNone/>
               <a:defRPr sz="975" b="1">
                 <a:solidFill>
                   <a:srgbClr val="A8C9B0"/>
@@ -9407,7 +9578,7 @@
             <a:r>
               <a:rPr sz="975" b="1">
                 <a:solidFill>
-                  <a:srgbClr val="A8C9B0"/>
+                  <a:srgbClr val="2C6B50"/>
                 </a:solidFill>
                 <a:latin typeface="Calibri"/>
                 <a:ea typeface="Calibri"/>
@@ -9454,7 +9625,7 @@
             <a:defPPr algn="l">
               <a:defRPr sz="1350" b="0">
                 <a:solidFill>
-                  <a:srgbClr val="FFFFFF"/>
+                  <a:srgbClr val="19332A"/>
                 </a:solidFill>
                 <a:latin typeface="Calibri"/>
                 <a:ea typeface="Calibri"/>
@@ -9464,6 +9635,7 @@
           </a:lstStyle>
           <a:p xmlns:a="http://schemas.openxmlformats.org/drawingml/2006/main">
             <a:pPr algn="l">
+              <a:buNone/>
               <a:defRPr sz="1350" b="0">
                 <a:solidFill>
                   <a:srgbClr val="FFFFFF"/>
@@ -9476,7 +9648,7 @@
             <a:r>
               <a:rPr sz="1350" b="0">
                 <a:solidFill>
-                  <a:srgbClr val="FFFFFF"/>
+                  <a:srgbClr val="19332A"/>
                 </a:solidFill>
                 <a:latin typeface="Calibri"/>
                 <a:ea typeface="Calibri"/>
@@ -9512,7 +9684,7 @@
             </a:avLst>
           </a:prstGeom>
           <a:solidFill xmlns:a="http://schemas.openxmlformats.org/drawingml/2006/main">
-            <a:srgbClr val="214C3D"/>
+            <a:srgbClr val="E9F0E9"/>
           </a:solidFill>
           <a:ln xmlns:a="http://schemas.openxmlformats.org/drawingml/2006/main" w="0">
             <a:noFill/>
@@ -9537,7 +9709,7 @@
         <p:spPr>
           <a:xfrm xmlns:a="http://schemas.openxmlformats.org/drawingml/2006/main">
             <a:off x="7277100" y="1752600"/>
-            <a:ext cx="3619500" cy="523875"/>
+            <a:ext cx="3619500" cy="266700"/>
           </a:xfrm>
           <a:prstGeom xmlns:a="http://schemas.openxmlformats.org/drawingml/2006/main" prst="rect">
             <a:avLst/>
@@ -9556,7 +9728,7 @@
             <a:defPPr algn="l">
               <a:defRPr sz="1050" b="1">
                 <a:solidFill>
-                  <a:srgbClr val="A8C9B0"/>
+                  <a:srgbClr val="2C6B50"/>
                 </a:solidFill>
                 <a:latin typeface="Calibri"/>
                 <a:ea typeface="Calibri"/>
@@ -9566,6 +9738,7 @@
           </a:lstStyle>
           <a:p xmlns:a="http://schemas.openxmlformats.org/drawingml/2006/main">
             <a:pPr algn="l">
+              <a:buNone/>
               <a:defRPr sz="1050" b="1">
                 <a:solidFill>
                   <a:srgbClr val="A8C9B0"/>
@@ -9578,36 +9751,13 @@
             <a:r>
               <a:rPr sz="1050" b="1">
                 <a:solidFill>
-                  <a:srgbClr val="A8C9B0"/>
+                  <a:srgbClr val="2C6B50"/>
                 </a:solidFill>
                 <a:latin typeface="Calibri"/>
                 <a:ea typeface="Calibri"/>
                 <a:cs typeface="Calibri"/>
               </a:rPr>
-              <a:t>A PRACTICAL</a:t>
-            </a:r>
-          </a:p>
-          <a:p xmlns:a="http://schemas.openxmlformats.org/drawingml/2006/main">
-            <a:pPr algn="l">
-              <a:defRPr sz="1050" b="1">
-                <a:solidFill>
-                  <a:srgbClr val="A8C9B0"/>
-                </a:solidFill>
-                <a:latin typeface="Calibri"/>
-                <a:ea typeface="Calibri"/>
-                <a:cs typeface="Calibri"/>
-              </a:defRPr>
-            </a:pPr>
-            <a:r>
-              <a:rPr sz="1050" b="1">
-                <a:solidFill>
-                  <a:srgbClr val="A8C9B0"/>
-                </a:solidFill>
-                <a:latin typeface="Calibri"/>
-                <a:ea typeface="Calibri"/>
-                <a:cs typeface="Calibri"/>
-              </a:rPr>
-              <a:t>OPPORTUNITY</a:t>
+              <a:t>POSSIBLE PATHWAY</a:t>
             </a:r>
           </a:p>
         </p:txBody>
@@ -9635,7 +9785,7 @@
             <a:avLst/>
           </a:prstGeom>
           <a:solidFill xmlns:a="http://schemas.openxmlformats.org/drawingml/2006/main">
-            <a:srgbClr val="436A59"/>
+            <a:srgbClr val="C8D6CC"/>
           </a:solidFill>
           <a:ln xmlns:a="http://schemas.openxmlformats.org/drawingml/2006/main" w="0">
             <a:noFill/>
@@ -9689,6 +9839,7 @@
           </a:lstStyle>
           <a:p xmlns:a="http://schemas.openxmlformats.org/drawingml/2006/main">
             <a:pPr algn="l">
+              <a:buNone/>
               <a:defRPr sz="1275" b="1">
                 <a:solidFill>
                   <a:srgbClr val="E9795B"/>
@@ -9748,7 +9899,7 @@
             <a:defPPr algn="l">
               <a:defRPr sz="975" b="1">
                 <a:solidFill>
-                  <a:srgbClr val="A8C9B0"/>
+                  <a:srgbClr val="2C6B50"/>
                 </a:solidFill>
                 <a:latin typeface="Calibri"/>
                 <a:ea typeface="Calibri"/>
@@ -9758,6 +9909,7 @@
           </a:lstStyle>
           <a:p xmlns:a="http://schemas.openxmlformats.org/drawingml/2006/main">
             <a:pPr algn="l">
+              <a:buNone/>
               <a:defRPr sz="975" b="1">
                 <a:solidFill>
                   <a:srgbClr val="A8C9B0"/>
@@ -9770,7 +9922,7 @@
             <a:r>
               <a:rPr sz="975" b="1">
                 <a:solidFill>
-                  <a:srgbClr val="A8C9B0"/>
+                  <a:srgbClr val="2C6B50"/>
                 </a:solidFill>
                 <a:latin typeface="Calibri"/>
                 <a:ea typeface="Calibri"/>
@@ -9817,7 +9969,7 @@
             <a:defPPr algn="l">
               <a:defRPr sz="1275" b="0">
                 <a:solidFill>
-                  <a:srgbClr val="FFFFFF"/>
+                  <a:srgbClr val="19332A"/>
                 </a:solidFill>
                 <a:latin typeface="Calibri"/>
                 <a:ea typeface="Calibri"/>
@@ -9827,6 +9979,7 @@
           </a:lstStyle>
           <a:p xmlns:a="http://schemas.openxmlformats.org/drawingml/2006/main">
             <a:pPr algn="l">
+              <a:buNone/>
               <a:defRPr sz="1275" b="0">
                 <a:solidFill>
                   <a:srgbClr val="FFFFFF"/>
@@ -9839,7 +9992,7 @@
             <a:r>
               <a:rPr sz="1275" b="0">
                 <a:solidFill>
-                  <a:srgbClr val="FFFFFF"/>
+                  <a:srgbClr val="19332A"/>
                 </a:solidFill>
                 <a:latin typeface="Calibri"/>
                 <a:ea typeface="Calibri"/>
@@ -9896,6 +10049,7 @@
           </a:lstStyle>
           <a:p xmlns:a="http://schemas.openxmlformats.org/drawingml/2006/main">
             <a:pPr algn="l">
+              <a:buNone/>
               <a:defRPr sz="1275" b="1">
                 <a:solidFill>
                   <a:srgbClr val="E9795B"/>
@@ -9955,7 +10109,7 @@
             <a:defPPr algn="l">
               <a:defRPr sz="975" b="1">
                 <a:solidFill>
-                  <a:srgbClr val="A8C9B0"/>
+                  <a:srgbClr val="2C6B50"/>
                 </a:solidFill>
                 <a:latin typeface="Calibri"/>
                 <a:ea typeface="Calibri"/>
@@ -9965,6 +10119,7 @@
           </a:lstStyle>
           <a:p xmlns:a="http://schemas.openxmlformats.org/drawingml/2006/main">
             <a:pPr algn="l">
+              <a:buNone/>
               <a:defRPr sz="975" b="1">
                 <a:solidFill>
                   <a:srgbClr val="A8C9B0"/>
@@ -9977,7 +10132,7 @@
             <a:r>
               <a:rPr sz="975" b="1">
                 <a:solidFill>
-                  <a:srgbClr val="A8C9B0"/>
+                  <a:srgbClr val="2C6B50"/>
                 </a:solidFill>
                 <a:latin typeface="Calibri"/>
                 <a:ea typeface="Calibri"/>
@@ -10024,7 +10179,7 @@
             <a:defPPr algn="l">
               <a:defRPr sz="1275" b="0">
                 <a:solidFill>
-                  <a:srgbClr val="FFFFFF"/>
+                  <a:srgbClr val="19332A"/>
                 </a:solidFill>
                 <a:latin typeface="Calibri"/>
                 <a:ea typeface="Calibri"/>
@@ -10034,6 +10189,7 @@
           </a:lstStyle>
           <a:p xmlns:a="http://schemas.openxmlformats.org/drawingml/2006/main">
             <a:pPr algn="l">
+              <a:buNone/>
               <a:defRPr sz="1275" b="0">
                 <a:solidFill>
                   <a:srgbClr val="FFFFFF"/>
@@ -10046,7 +10202,7 @@
             <a:r>
               <a:rPr sz="1275" b="0">
                 <a:solidFill>
-                  <a:srgbClr val="FFFFFF"/>
+                  <a:srgbClr val="19332A"/>
                 </a:solidFill>
                 <a:latin typeface="Calibri"/>
                 <a:ea typeface="Calibri"/>
@@ -10103,6 +10259,7 @@
           </a:lstStyle>
           <a:p xmlns:a="http://schemas.openxmlformats.org/drawingml/2006/main">
             <a:pPr algn="l">
+              <a:buNone/>
               <a:defRPr sz="1275" b="1">
                 <a:solidFill>
                   <a:srgbClr val="E9795B"/>
@@ -10162,7 +10319,7 @@
             <a:defPPr algn="l">
               <a:defRPr sz="975" b="1">
                 <a:solidFill>
-                  <a:srgbClr val="A8C9B0"/>
+                  <a:srgbClr val="2C6B50"/>
                 </a:solidFill>
                 <a:latin typeface="Calibri"/>
                 <a:ea typeface="Calibri"/>
@@ -10172,6 +10329,7 @@
           </a:lstStyle>
           <a:p xmlns:a="http://schemas.openxmlformats.org/drawingml/2006/main">
             <a:pPr algn="l">
+              <a:buNone/>
               <a:defRPr sz="975" b="1">
                 <a:solidFill>
                   <a:srgbClr val="A8C9B0"/>
@@ -10184,7 +10342,7 @@
             <a:r>
               <a:rPr sz="975" b="1">
                 <a:solidFill>
-                  <a:srgbClr val="A8C9B0"/>
+                  <a:srgbClr val="2C6B50"/>
                 </a:solidFill>
                 <a:latin typeface="Calibri"/>
                 <a:ea typeface="Calibri"/>
@@ -10231,7 +10389,7 @@
             <a:defPPr algn="l">
               <a:defRPr sz="1275" b="0">
                 <a:solidFill>
-                  <a:srgbClr val="FFFFFF"/>
+                  <a:srgbClr val="19332A"/>
                 </a:solidFill>
                 <a:latin typeface="Calibri"/>
                 <a:ea typeface="Calibri"/>
@@ -10241,6 +10399,7 @@
           </a:lstStyle>
           <a:p xmlns:a="http://schemas.openxmlformats.org/drawingml/2006/main">
             <a:pPr algn="l">
+              <a:buNone/>
               <a:defRPr sz="1275" b="0">
                 <a:solidFill>
                   <a:srgbClr val="FFFFFF"/>
@@ -10253,7 +10412,7 @@
             <a:r>
               <a:rPr sz="1275" b="0">
                 <a:solidFill>
-                  <a:srgbClr val="FFFFFF"/>
+                  <a:srgbClr val="19332A"/>
                 </a:solidFill>
                 <a:latin typeface="Calibri"/>
                 <a:ea typeface="Calibri"/>
@@ -10300,7 +10459,7 @@
             <a:defPPr algn="l">
               <a:defRPr sz="1125" b="1">
                 <a:solidFill>
-                  <a:srgbClr val="FFFFFF"/>
+                  <a:srgbClr val="60756A"/>
                 </a:solidFill>
                 <a:latin typeface="Calibri"/>
                 <a:ea typeface="Calibri"/>
@@ -10310,6 +10469,7 @@
           </a:lstStyle>
           <a:p xmlns:a="http://schemas.openxmlformats.org/drawingml/2006/main">
             <a:pPr algn="l">
+              <a:buNone/>
               <a:defRPr sz="1125" b="1">
                 <a:solidFill>
                   <a:srgbClr val="FFFFFF"/>
@@ -10322,13 +10482,82 @@
             <a:r>
               <a:rPr sz="1125" b="1">
                 <a:solidFill>
-                  <a:srgbClr val="FFFFFF"/>
+                  <a:srgbClr val="60756A"/>
                 </a:solidFill>
                 <a:latin typeface="Calibri"/>
                 <a:ea typeface="Calibri"/>
                 <a:cs typeface="Calibri"/>
               </a:rPr>
               <a:t>Prototype does not calculate material use, carbon, or device energy.</a:t>
+            </a:r>
+          </a:p>
+        </p:txBody>
+      </p:sp>
+      <p:sp>
+        <p:nvSpPr>
+          <p:cNvPr id="28" name="page-number">
+            <a:extLst xmlns:a="http://schemas.openxmlformats.org/drawingml/2006/main">
+              <a:ext uri="{FF2B5EF4-FFF2-40B4-BE49-F238E27FC236}">
+                <a16:creationId xmlns:a16="http://schemas.microsoft.com/office/drawing/2014/main" id="{AC22A0A5-57BD-450A-A4D4-ED01B1DE554F}"/>
+              </a:ext>
+            </a:extLst>
+          </p:cNvPr>
+          <p:cNvSpPr>
+            <a:spLocks xmlns:a="http://schemas.openxmlformats.org/drawingml/2006/main" noGrp="1"/>
+          </p:cNvSpPr>
+          <p:nvPr/>
+        </p:nvSpPr>
+        <p:spPr>
+          <a:xfrm xmlns:a="http://schemas.openxmlformats.org/drawingml/2006/main">
+            <a:off x="11163300" y="6362700"/>
+            <a:ext cx="457200" cy="171450"/>
+          </a:xfrm>
+          <a:prstGeom xmlns:a="http://schemas.openxmlformats.org/drawingml/2006/main" prst="rect">
+            <a:avLst/>
+          </a:prstGeom>
+          <a:noFill xmlns:a="http://schemas.openxmlformats.org/drawingml/2006/main"/>
+          <a:ln xmlns:a="http://schemas.openxmlformats.org/drawingml/2006/main" w="0">
+            <a:noFill/>
+            <a:prstDash val="solid"/>
+          </a:ln>
+        </p:spPr>
+        <p:txBody>
+          <a:bodyPr xmlns:a="http://schemas.openxmlformats.org/drawingml/2006/main" wrap="square" lIns="0" tIns="0" rIns="0" bIns="0" anchor="t">
+            <a:normAutofit fontScale="100000"/>
+          </a:bodyPr>
+          <a:lstStyle xmlns:a="http://schemas.openxmlformats.org/drawingml/2006/main">
+            <a:defPPr algn="r">
+              <a:defRPr sz="900" b="1">
+                <a:solidFill>
+                  <a:srgbClr val="60756A"/>
+                </a:solidFill>
+                <a:latin typeface="Calibri"/>
+                <a:ea typeface="Calibri"/>
+                <a:cs typeface="Calibri"/>
+              </a:defRPr>
+            </a:defPPr>
+          </a:lstStyle>
+          <a:p xmlns:a="http://schemas.openxmlformats.org/drawingml/2006/main">
+            <a:pPr algn="r">
+              <a:defRPr sz="900" b="1">
+                <a:solidFill>
+                  <a:srgbClr val="60756A"/>
+                </a:solidFill>
+                <a:latin typeface="Calibri"/>
+                <a:ea typeface="Calibri"/>
+                <a:cs typeface="Calibri"/>
+              </a:defRPr>
+            </a:pPr>
+            <a:r>
+              <a:rPr sz="900" b="1">
+                <a:solidFill>
+                  <a:srgbClr val="60756A"/>
+                </a:solidFill>
+                <a:latin typeface="Calibri"/>
+                <a:ea typeface="Calibri"/>
+                <a:cs typeface="Calibri"/>
+              </a:rPr>
+              <a:t>06</a:t>
             </a:r>
           </a:p>
         </p:txBody>

</xml_diff>